<commit_message>
docs update for go aggregations
</commit_message>
<xml_diff>
--- a/media/images.pptx
+++ b/media/images.pptx
@@ -13,6 +13,7 @@
     <p:sldId id="263" r:id="rId7"/>
     <p:sldId id="265" r:id="rId8"/>
     <p:sldId id="266" r:id="rId9"/>
+    <p:sldId id="267" r:id="rId10"/>
   </p:sldIdLst>
   <p:sldSz cx="12192000" cy="6858000"/>
   <p:notesSz cx="6858000" cy="9144000"/>
@@ -248,7 +249,7 @@
           <a:p>
             <a:fld id="{B3D53CF9-C767-4936-92E6-BD864E96BA87}" type="datetimeFigureOut">
               <a:rPr lang="en-US" smtClean="0"/>
-              <a:t>2/16/26</a:t>
+              <a:t>8/28/26</a:t>
             </a:fld>
             <a:endParaRPr lang="en-US"/>
           </a:p>
@@ -416,7 +417,7 @@
           <a:p>
             <a:fld id="{B3D53CF9-C767-4936-92E6-BD864E96BA87}" type="datetimeFigureOut">
               <a:rPr lang="en-US" smtClean="0"/>
-              <a:t>2/16/26</a:t>
+              <a:t>8/28/26</a:t>
             </a:fld>
             <a:endParaRPr lang="en-US"/>
           </a:p>
@@ -594,7 +595,7 @@
           <a:p>
             <a:fld id="{B3D53CF9-C767-4936-92E6-BD864E96BA87}" type="datetimeFigureOut">
               <a:rPr lang="en-US" smtClean="0"/>
-              <a:t>2/16/26</a:t>
+              <a:t>8/28/26</a:t>
             </a:fld>
             <a:endParaRPr lang="en-US"/>
           </a:p>
@@ -762,7 +763,7 @@
           <a:p>
             <a:fld id="{B3D53CF9-C767-4936-92E6-BD864E96BA87}" type="datetimeFigureOut">
               <a:rPr lang="en-US" smtClean="0"/>
-              <a:t>2/16/26</a:t>
+              <a:t>8/28/26</a:t>
             </a:fld>
             <a:endParaRPr lang="en-US"/>
           </a:p>
@@ -1007,7 +1008,7 @@
           <a:p>
             <a:fld id="{B3D53CF9-C767-4936-92E6-BD864E96BA87}" type="datetimeFigureOut">
               <a:rPr lang="en-US" smtClean="0"/>
-              <a:t>2/16/26</a:t>
+              <a:t>8/28/26</a:t>
             </a:fld>
             <a:endParaRPr lang="en-US"/>
           </a:p>
@@ -1236,7 +1237,7 @@
           <a:p>
             <a:fld id="{B3D53CF9-C767-4936-92E6-BD864E96BA87}" type="datetimeFigureOut">
               <a:rPr lang="en-US" smtClean="0"/>
-              <a:t>2/16/26</a:t>
+              <a:t>8/28/26</a:t>
             </a:fld>
             <a:endParaRPr lang="en-US"/>
           </a:p>
@@ -1600,7 +1601,7 @@
           <a:p>
             <a:fld id="{B3D53CF9-C767-4936-92E6-BD864E96BA87}" type="datetimeFigureOut">
               <a:rPr lang="en-US" smtClean="0"/>
-              <a:t>2/16/26</a:t>
+              <a:t>8/28/26</a:t>
             </a:fld>
             <a:endParaRPr lang="en-US"/>
           </a:p>
@@ -1717,7 +1718,7 @@
           <a:p>
             <a:fld id="{B3D53CF9-C767-4936-92E6-BD864E96BA87}" type="datetimeFigureOut">
               <a:rPr lang="en-US" smtClean="0"/>
-              <a:t>2/16/26</a:t>
+              <a:t>8/28/26</a:t>
             </a:fld>
             <a:endParaRPr lang="en-US"/>
           </a:p>
@@ -1812,7 +1813,7 @@
           <a:p>
             <a:fld id="{B3D53CF9-C767-4936-92E6-BD864E96BA87}" type="datetimeFigureOut">
               <a:rPr lang="en-US" smtClean="0"/>
-              <a:t>2/16/26</a:t>
+              <a:t>8/28/26</a:t>
             </a:fld>
             <a:endParaRPr lang="en-US"/>
           </a:p>
@@ -2087,7 +2088,7 @@
           <a:p>
             <a:fld id="{B3D53CF9-C767-4936-92E6-BD864E96BA87}" type="datetimeFigureOut">
               <a:rPr lang="en-US" smtClean="0"/>
-              <a:t>2/16/26</a:t>
+              <a:t>8/28/26</a:t>
             </a:fld>
             <a:endParaRPr lang="en-US"/>
           </a:p>
@@ -2339,7 +2340,7 @@
           <a:p>
             <a:fld id="{B3D53CF9-C767-4936-92E6-BD864E96BA87}" type="datetimeFigureOut">
               <a:rPr lang="en-US" smtClean="0"/>
-              <a:t>2/16/26</a:t>
+              <a:t>8/28/26</a:t>
             </a:fld>
             <a:endParaRPr lang="en-US"/>
           </a:p>
@@ -2550,7 +2551,7 @@
           <a:p>
             <a:fld id="{B3D53CF9-C767-4936-92E6-BD864E96BA87}" type="datetimeFigureOut">
               <a:rPr lang="en-US" smtClean="0"/>
-              <a:t>2/16/26</a:t>
+              <a:t>8/28/26</a:t>
             </a:fld>
             <a:endParaRPr lang="en-US"/>
           </a:p>
@@ -17841,6 +17842,1926 @@
 </p:sld>
 </file>
 
+<file path=ppt/slides/slide9.xml><?xml version="1.0" encoding="utf-8"?>
+<p:sld xmlns:a="http://schemas.openxmlformats.org/drawingml/2006/main" xmlns:r="http://schemas.openxmlformats.org/officeDocument/2006/relationships" xmlns:p="http://schemas.openxmlformats.org/presentationml/2006/main">
+  <p:cSld>
+    <p:spTree>
+      <p:nvGrpSpPr>
+        <p:cNvPr id="1" name="">
+          <a:extLst>
+            <a:ext uri="{FF2B5EF4-FFF2-40B4-BE49-F238E27FC236}">
+              <a16:creationId xmlns:a16="http://schemas.microsoft.com/office/drawing/2014/main" id="{2D147FAF-DFD8-CF5A-0868-6DE29227C00A}"/>
+            </a:ext>
+          </a:extLst>
+        </p:cNvPr>
+        <p:cNvGrpSpPr/>
+        <p:nvPr/>
+      </p:nvGrpSpPr>
+      <p:grpSpPr>
+        <a:xfrm>
+          <a:off x="0" y="0"/>
+          <a:ext cx="0" cy="0"/>
+          <a:chOff x="0" y="0"/>
+          <a:chExt cx="0" cy="0"/>
+        </a:xfrm>
+      </p:grpSpPr>
+      <p:sp>
+        <p:nvSpPr>
+          <p:cNvPr id="54" name="Rectangle 53">
+            <a:extLst>
+              <a:ext uri="{FF2B5EF4-FFF2-40B4-BE49-F238E27FC236}">
+                <a16:creationId xmlns:a16="http://schemas.microsoft.com/office/drawing/2014/main" id="{FAC9F8A2-CB6D-EBCD-B2C0-FCC7D5567BE8}"/>
+              </a:ext>
+            </a:extLst>
+          </p:cNvPr>
+          <p:cNvSpPr/>
+          <p:nvPr/>
+        </p:nvSpPr>
+        <p:spPr>
+          <a:xfrm>
+            <a:off x="6235086" y="1253746"/>
+            <a:ext cx="3440348" cy="5150279"/>
+          </a:xfrm>
+          <a:prstGeom prst="rect">
+            <a:avLst/>
+          </a:prstGeom>
+          <a:solidFill>
+            <a:schemeClr val="accent3">
+              <a:lumMod val="40000"/>
+              <a:lumOff val="60000"/>
+            </a:schemeClr>
+          </a:solidFill>
+        </p:spPr>
+        <p:style>
+          <a:lnRef idx="2">
+            <a:schemeClr val="accent5">
+              <a:shade val="50000"/>
+            </a:schemeClr>
+          </a:lnRef>
+          <a:fillRef idx="1">
+            <a:schemeClr val="accent5"/>
+          </a:fillRef>
+          <a:effectRef idx="0">
+            <a:schemeClr val="accent5"/>
+          </a:effectRef>
+          <a:fontRef idx="minor">
+            <a:schemeClr val="lt1"/>
+          </a:fontRef>
+        </p:style>
+        <p:txBody>
+          <a:bodyPr rtlCol="0" anchor="t"/>
+          <a:lstStyle/>
+          <a:p>
+            <a:r>
+              <a:rPr lang="en-US" b="1" dirty="0">
+                <a:solidFill>
+                  <a:schemeClr val="tx1"/>
+                </a:solidFill>
+              </a:rPr>
+              <a:t>IP Address Sequential Ranges</a:t>
+            </a:r>
+          </a:p>
+          <a:p>
+            <a:pPr algn="ctr"/>
+            <a:r>
+              <a:rPr lang="en-US" sz="3200" dirty="0"/>
+              <a:t>                                     </a:t>
+            </a:r>
+            <a:endParaRPr lang="en-US" sz="5400" dirty="0"/>
+          </a:p>
+        </p:txBody>
+      </p:sp>
+      <p:sp>
+        <p:nvSpPr>
+          <p:cNvPr id="888" name="Rectangle 887">
+            <a:extLst>
+              <a:ext uri="{FF2B5EF4-FFF2-40B4-BE49-F238E27FC236}">
+                <a16:creationId xmlns:a16="http://schemas.microsoft.com/office/drawing/2014/main" id="{BF7E1F16-16D6-BA5C-6DE2-A18817429A07}"/>
+              </a:ext>
+            </a:extLst>
+          </p:cNvPr>
+          <p:cNvSpPr/>
+          <p:nvPr/>
+        </p:nvSpPr>
+        <p:spPr>
+          <a:xfrm>
+            <a:off x="9779225" y="2151939"/>
+            <a:ext cx="2239977" cy="4252086"/>
+          </a:xfrm>
+          <a:prstGeom prst="rect">
+            <a:avLst/>
+          </a:prstGeom>
+          <a:solidFill>
+            <a:schemeClr val="accent3">
+              <a:lumMod val="40000"/>
+              <a:lumOff val="60000"/>
+            </a:schemeClr>
+          </a:solidFill>
+        </p:spPr>
+        <p:style>
+          <a:lnRef idx="2">
+            <a:schemeClr val="accent5">
+              <a:shade val="50000"/>
+            </a:schemeClr>
+          </a:lnRef>
+          <a:fillRef idx="1">
+            <a:schemeClr val="accent5"/>
+          </a:fillRef>
+          <a:effectRef idx="0">
+            <a:schemeClr val="accent5"/>
+          </a:effectRef>
+          <a:fontRef idx="minor">
+            <a:schemeClr val="lt1"/>
+          </a:fontRef>
+        </p:style>
+        <p:txBody>
+          <a:bodyPr rtlCol="0" anchor="t"/>
+          <a:lstStyle/>
+          <a:p>
+            <a:r>
+              <a:rPr lang="en-US" b="1" dirty="0">
+                <a:solidFill>
+                  <a:schemeClr val="tx1"/>
+                </a:solidFill>
+              </a:rPr>
+              <a:t>IP Address  Subnets</a:t>
+            </a:r>
+          </a:p>
+          <a:p>
+            <a:pPr algn="ctr"/>
+            <a:r>
+              <a:rPr lang="en-US" sz="3200" dirty="0"/>
+              <a:t>                                     </a:t>
+            </a:r>
+            <a:endParaRPr lang="en-US" sz="5400" dirty="0"/>
+          </a:p>
+        </p:txBody>
+      </p:sp>
+      <p:sp>
+        <p:nvSpPr>
+          <p:cNvPr id="887" name="Rectangle 886">
+            <a:extLst>
+              <a:ext uri="{FF2B5EF4-FFF2-40B4-BE49-F238E27FC236}">
+                <a16:creationId xmlns:a16="http://schemas.microsoft.com/office/drawing/2014/main" id="{DE518862-DA22-16A1-087F-264172866CC9}"/>
+              </a:ext>
+            </a:extLst>
+          </p:cNvPr>
+          <p:cNvSpPr/>
+          <p:nvPr/>
+        </p:nvSpPr>
+        <p:spPr>
+          <a:xfrm>
+            <a:off x="257399" y="1066788"/>
+            <a:ext cx="5872585" cy="5352951"/>
+          </a:xfrm>
+          <a:prstGeom prst="rect">
+            <a:avLst/>
+          </a:prstGeom>
+          <a:solidFill>
+            <a:schemeClr val="accent3">
+              <a:lumMod val="40000"/>
+              <a:lumOff val="60000"/>
+            </a:schemeClr>
+          </a:solidFill>
+        </p:spPr>
+        <p:style>
+          <a:lnRef idx="2">
+            <a:schemeClr val="accent5">
+              <a:shade val="50000"/>
+            </a:schemeClr>
+          </a:lnRef>
+          <a:fillRef idx="1">
+            <a:schemeClr val="accent5"/>
+          </a:fillRef>
+          <a:effectRef idx="0">
+            <a:schemeClr val="accent5"/>
+          </a:effectRef>
+          <a:fontRef idx="minor">
+            <a:schemeClr val="lt1"/>
+          </a:fontRef>
+        </p:style>
+        <p:txBody>
+          <a:bodyPr rtlCol="0" anchor="t"/>
+          <a:lstStyle/>
+          <a:p>
+            <a:r>
+              <a:rPr lang="en-US" b="1" dirty="0">
+                <a:solidFill>
+                  <a:schemeClr val="tx1"/>
+                </a:solidFill>
+              </a:rPr>
+              <a:t>IP Address Collections</a:t>
+            </a:r>
+          </a:p>
+          <a:p>
+            <a:pPr algn="ctr"/>
+            <a:r>
+              <a:rPr lang="en-US" sz="3200" dirty="0"/>
+              <a:t>                                      </a:t>
+            </a:r>
+            <a:endParaRPr lang="en-US" sz="5400" dirty="0"/>
+          </a:p>
+        </p:txBody>
+      </p:sp>
+      <p:sp>
+        <p:nvSpPr>
+          <p:cNvPr id="4" name="Rectangle 3">
+            <a:extLst>
+              <a:ext uri="{FF2B5EF4-FFF2-40B4-BE49-F238E27FC236}">
+                <a16:creationId xmlns:a16="http://schemas.microsoft.com/office/drawing/2014/main" id="{1D4DA567-7BB0-DBFA-6106-D14E7B6E33C8}"/>
+              </a:ext>
+            </a:extLst>
+          </p:cNvPr>
+          <p:cNvSpPr/>
+          <p:nvPr/>
+        </p:nvSpPr>
+        <p:spPr>
+          <a:xfrm>
+            <a:off x="5985881" y="143446"/>
+            <a:ext cx="1820092" cy="278946"/>
+          </a:xfrm>
+          <a:prstGeom prst="rect">
+            <a:avLst/>
+          </a:prstGeom>
+          <a:solidFill>
+            <a:srgbClr val="7030A0"/>
+          </a:solidFill>
+        </p:spPr>
+        <p:style>
+          <a:lnRef idx="2">
+            <a:schemeClr val="accent1">
+              <a:shade val="50000"/>
+            </a:schemeClr>
+          </a:lnRef>
+          <a:fillRef idx="1">
+            <a:schemeClr val="accent1"/>
+          </a:fillRef>
+          <a:effectRef idx="0">
+            <a:schemeClr val="accent1"/>
+          </a:effectRef>
+          <a:fontRef idx="minor">
+            <a:schemeClr val="lt1"/>
+          </a:fontRef>
+        </p:style>
+        <p:txBody>
+          <a:bodyPr rtlCol="0" anchor="ctr"/>
+          <a:lstStyle/>
+          <a:p>
+            <a:pPr algn="ctr"/>
+            <a:r>
+              <a:rPr lang="en-US" sz="1400" dirty="0" err="1"/>
+              <a:t>IPAddressAggregation</a:t>
+            </a:r>
+            <a:endParaRPr lang="en-US" sz="1400" dirty="0"/>
+          </a:p>
+        </p:txBody>
+      </p:sp>
+      <p:sp>
+        <p:nvSpPr>
+          <p:cNvPr id="25" name="Rectangle 24">
+            <a:extLst>
+              <a:ext uri="{FF2B5EF4-FFF2-40B4-BE49-F238E27FC236}">
+                <a16:creationId xmlns:a16="http://schemas.microsoft.com/office/drawing/2014/main" id="{685DEBAF-F957-2517-68AD-6C8B44A57A29}"/>
+              </a:ext>
+            </a:extLst>
+          </p:cNvPr>
+          <p:cNvSpPr/>
+          <p:nvPr/>
+        </p:nvSpPr>
+        <p:spPr>
+          <a:xfrm>
+            <a:off x="324686" y="4949578"/>
+            <a:ext cx="3698674" cy="291194"/>
+          </a:xfrm>
+          <a:prstGeom prst="rect">
+            <a:avLst/>
+          </a:prstGeom>
+          <a:solidFill>
+            <a:schemeClr val="accent6">
+              <a:lumMod val="75000"/>
+            </a:schemeClr>
+          </a:solidFill>
+        </p:spPr>
+        <p:style>
+          <a:lnRef idx="2">
+            <a:schemeClr val="accent1">
+              <a:shade val="50000"/>
+            </a:schemeClr>
+          </a:lnRef>
+          <a:fillRef idx="1">
+            <a:schemeClr val="accent1"/>
+          </a:fillRef>
+          <a:effectRef idx="0">
+            <a:schemeClr val="accent1"/>
+          </a:effectRef>
+          <a:fontRef idx="minor">
+            <a:schemeClr val="lt1"/>
+          </a:fontRef>
+        </p:style>
+        <p:txBody>
+          <a:bodyPr rtlCol="0" anchor="ctr"/>
+          <a:lstStyle/>
+          <a:p>
+            <a:pPr algn="ctr"/>
+            <a:r>
+              <a:rPr lang="en-US" sz="1400" dirty="0" err="1"/>
+              <a:t>ContainmentTrieBase</a:t>
+            </a:r>
+            <a:r>
+              <a:rPr lang="en-US" sz="1400" dirty="0"/>
+              <a:t>[</a:t>
+            </a:r>
+            <a:r>
+              <a:rPr lang="en-US" sz="1400" dirty="0" err="1"/>
+              <a:t>IPAddressTypeConstraint</a:t>
+            </a:r>
+            <a:r>
+              <a:rPr lang="en-US" sz="1400" dirty="0"/>
+              <a:t>]</a:t>
+            </a:r>
+          </a:p>
+        </p:txBody>
+      </p:sp>
+      <p:cxnSp>
+        <p:nvCxnSpPr>
+          <p:cNvPr id="26" name="Straight Arrow Connector 25">
+            <a:extLst>
+              <a:ext uri="{FF2B5EF4-FFF2-40B4-BE49-F238E27FC236}">
+                <a16:creationId xmlns:a16="http://schemas.microsoft.com/office/drawing/2014/main" id="{6FCDA2BB-EC92-03F2-BF1B-95D41E2DD0FD}"/>
+              </a:ext>
+            </a:extLst>
+          </p:cNvPr>
+          <p:cNvCxnSpPr>
+            <a:cxnSpLocks/>
+            <a:stCxn id="16" idx="0"/>
+            <a:endCxn id="4" idx="2"/>
+          </p:cNvCxnSpPr>
+          <p:nvPr/>
+        </p:nvCxnSpPr>
+        <p:spPr>
+          <a:xfrm flipV="1">
+            <a:off x="5044855" y="422392"/>
+            <a:ext cx="1851072" cy="1961355"/>
+          </a:xfrm>
+          <a:prstGeom prst="straightConnector1">
+            <a:avLst/>
+          </a:prstGeom>
+          <a:ln w="44450" cap="flat">
+            <a:solidFill>
+              <a:schemeClr val="tx1"/>
+            </a:solidFill>
+            <a:miter lim="800000"/>
+            <a:headEnd w="lg" len="med"/>
+            <a:tailEnd type="triangle"/>
+          </a:ln>
+        </p:spPr>
+        <p:style>
+          <a:lnRef idx="3">
+            <a:schemeClr val="accent1"/>
+          </a:lnRef>
+          <a:fillRef idx="0">
+            <a:schemeClr val="accent1"/>
+          </a:fillRef>
+          <a:effectRef idx="2">
+            <a:schemeClr val="accent1"/>
+          </a:effectRef>
+          <a:fontRef idx="minor">
+            <a:schemeClr val="tx1"/>
+          </a:fontRef>
+        </p:style>
+      </p:cxnSp>
+      <p:cxnSp>
+        <p:nvCxnSpPr>
+          <p:cNvPr id="38" name="Straight Arrow Connector 37">
+            <a:extLst>
+              <a:ext uri="{FF2B5EF4-FFF2-40B4-BE49-F238E27FC236}">
+                <a16:creationId xmlns:a16="http://schemas.microsoft.com/office/drawing/2014/main" id="{94D79E72-713A-32CF-A45C-B4F315208800}"/>
+              </a:ext>
+            </a:extLst>
+          </p:cNvPr>
+          <p:cNvCxnSpPr>
+            <a:cxnSpLocks/>
+            <a:stCxn id="25" idx="0"/>
+            <a:endCxn id="23" idx="2"/>
+          </p:cNvCxnSpPr>
+          <p:nvPr/>
+        </p:nvCxnSpPr>
+        <p:spPr>
+          <a:xfrm flipV="1">
+            <a:off x="2174023" y="4371839"/>
+            <a:ext cx="1784234" cy="577739"/>
+          </a:xfrm>
+          <a:prstGeom prst="straightConnector1">
+            <a:avLst/>
+          </a:prstGeom>
+          <a:ln w="44450" cap="flat">
+            <a:solidFill>
+              <a:schemeClr val="tx1"/>
+            </a:solidFill>
+            <a:miter lim="800000"/>
+            <a:headEnd w="lg" len="med"/>
+            <a:tailEnd type="triangle"/>
+          </a:ln>
+        </p:spPr>
+        <p:style>
+          <a:lnRef idx="3">
+            <a:schemeClr val="accent1"/>
+          </a:lnRef>
+          <a:fillRef idx="0">
+            <a:schemeClr val="accent1"/>
+          </a:fillRef>
+          <a:effectRef idx="2">
+            <a:schemeClr val="accent1"/>
+          </a:effectRef>
+          <a:fontRef idx="minor">
+            <a:schemeClr val="tx1"/>
+          </a:fontRef>
+        </p:style>
+      </p:cxnSp>
+      <p:sp>
+        <p:nvSpPr>
+          <p:cNvPr id="203" name="Rectangle 202">
+            <a:extLst>
+              <a:ext uri="{FF2B5EF4-FFF2-40B4-BE49-F238E27FC236}">
+                <a16:creationId xmlns:a16="http://schemas.microsoft.com/office/drawing/2014/main" id="{6D470EA9-8BF8-05E4-54E5-BF3211A07BC3}"/>
+              </a:ext>
+            </a:extLst>
+          </p:cNvPr>
+          <p:cNvSpPr/>
+          <p:nvPr/>
+        </p:nvSpPr>
+        <p:spPr>
+          <a:xfrm>
+            <a:off x="2516566" y="5791212"/>
+            <a:ext cx="3556574" cy="288375"/>
+          </a:xfrm>
+          <a:prstGeom prst="rect">
+            <a:avLst/>
+          </a:prstGeom>
+          <a:solidFill>
+            <a:schemeClr val="accent6">
+              <a:lumMod val="75000"/>
+            </a:schemeClr>
+          </a:solidFill>
+        </p:spPr>
+        <p:style>
+          <a:lnRef idx="2">
+            <a:schemeClr val="accent1">
+              <a:shade val="50000"/>
+            </a:schemeClr>
+          </a:lnRef>
+          <a:fillRef idx="1">
+            <a:schemeClr val="accent1"/>
+          </a:fillRef>
+          <a:effectRef idx="0">
+            <a:schemeClr val="accent1"/>
+          </a:effectRef>
+          <a:fontRef idx="minor">
+            <a:schemeClr val="lt1"/>
+          </a:fontRef>
+        </p:style>
+        <p:txBody>
+          <a:bodyPr rtlCol="0" anchor="ctr"/>
+          <a:lstStyle/>
+          <a:p>
+            <a:pPr algn="ctr"/>
+            <a:r>
+              <a:rPr lang="en-US" sz="1400" dirty="0" err="1"/>
+              <a:t>SequentialRangeList</a:t>
+            </a:r>
+            <a:r>
+              <a:rPr lang="en-US" sz="1400" dirty="0"/>
+              <a:t>[</a:t>
+            </a:r>
+            <a:r>
+              <a:rPr lang="en-US" sz="1400" dirty="0" err="1"/>
+              <a:t>IPAddressTypeConstraint</a:t>
+            </a:r>
+            <a:r>
+              <a:rPr lang="en-US" sz="1400" dirty="0"/>
+              <a:t>]</a:t>
+            </a:r>
+          </a:p>
+        </p:txBody>
+      </p:sp>
+      <p:cxnSp>
+        <p:nvCxnSpPr>
+          <p:cNvPr id="205" name="Straight Arrow Connector 204">
+            <a:extLst>
+              <a:ext uri="{FF2B5EF4-FFF2-40B4-BE49-F238E27FC236}">
+                <a16:creationId xmlns:a16="http://schemas.microsoft.com/office/drawing/2014/main" id="{CD70B1F9-359F-ABFD-9744-90A2D4FEED36}"/>
+              </a:ext>
+            </a:extLst>
+          </p:cNvPr>
+          <p:cNvCxnSpPr>
+            <a:cxnSpLocks/>
+            <a:stCxn id="203" idx="0"/>
+            <a:endCxn id="23" idx="2"/>
+          </p:cNvCxnSpPr>
+          <p:nvPr/>
+        </p:nvCxnSpPr>
+        <p:spPr>
+          <a:xfrm flipH="1" flipV="1">
+            <a:off x="3958257" y="4371839"/>
+            <a:ext cx="336596" cy="1419373"/>
+          </a:xfrm>
+          <a:prstGeom prst="straightConnector1">
+            <a:avLst/>
+          </a:prstGeom>
+          <a:ln w="44450" cap="flat">
+            <a:solidFill>
+              <a:schemeClr val="tx1"/>
+            </a:solidFill>
+            <a:miter lim="800000"/>
+            <a:headEnd w="lg" len="med"/>
+            <a:tailEnd type="triangle"/>
+          </a:ln>
+        </p:spPr>
+        <p:style>
+          <a:lnRef idx="3">
+            <a:schemeClr val="accent1"/>
+          </a:lnRef>
+          <a:fillRef idx="0">
+            <a:schemeClr val="accent1"/>
+          </a:fillRef>
+          <a:effectRef idx="2">
+            <a:schemeClr val="accent1"/>
+          </a:effectRef>
+          <a:fontRef idx="minor">
+            <a:schemeClr val="tx1"/>
+          </a:fontRef>
+        </p:style>
+      </p:cxnSp>
+      <p:sp>
+        <p:nvSpPr>
+          <p:cNvPr id="332" name="Rectangle 331">
+            <a:extLst>
+              <a:ext uri="{FF2B5EF4-FFF2-40B4-BE49-F238E27FC236}">
+                <a16:creationId xmlns:a16="http://schemas.microsoft.com/office/drawing/2014/main" id="{F1DCD5C1-2D07-EF64-EEBA-15BCB316A85C}"/>
+              </a:ext>
+            </a:extLst>
+          </p:cNvPr>
+          <p:cNvSpPr/>
+          <p:nvPr/>
+        </p:nvSpPr>
+        <p:spPr>
+          <a:xfrm>
+            <a:off x="10329644" y="4642472"/>
+            <a:ext cx="1102449" cy="269281"/>
+          </a:xfrm>
+          <a:prstGeom prst="rect">
+            <a:avLst/>
+          </a:prstGeom>
+          <a:solidFill>
+            <a:schemeClr val="accent6">
+              <a:lumMod val="75000"/>
+            </a:schemeClr>
+          </a:solidFill>
+        </p:spPr>
+        <p:style>
+          <a:lnRef idx="2">
+            <a:schemeClr val="accent1">
+              <a:shade val="50000"/>
+            </a:schemeClr>
+          </a:lnRef>
+          <a:fillRef idx="1">
+            <a:schemeClr val="accent1"/>
+          </a:fillRef>
+          <a:effectRef idx="0">
+            <a:schemeClr val="accent1"/>
+          </a:effectRef>
+          <a:fontRef idx="minor">
+            <a:schemeClr val="lt1"/>
+          </a:fontRef>
+        </p:style>
+        <p:txBody>
+          <a:bodyPr rtlCol="0" anchor="ctr"/>
+          <a:lstStyle/>
+          <a:p>
+            <a:pPr algn="ctr"/>
+            <a:r>
+              <a:rPr lang="en-US" sz="1400" dirty="0" err="1"/>
+              <a:t>IPAddress</a:t>
+            </a:r>
+            <a:endParaRPr lang="en-US" sz="1400" dirty="0"/>
+          </a:p>
+        </p:txBody>
+      </p:sp>
+      <p:sp>
+        <p:nvSpPr>
+          <p:cNvPr id="334" name="Rectangle 333">
+            <a:extLst>
+              <a:ext uri="{FF2B5EF4-FFF2-40B4-BE49-F238E27FC236}">
+                <a16:creationId xmlns:a16="http://schemas.microsoft.com/office/drawing/2014/main" id="{AEAD136F-FC0A-A415-2F7C-C820515BA0B9}"/>
+              </a:ext>
+            </a:extLst>
+          </p:cNvPr>
+          <p:cNvSpPr/>
+          <p:nvPr/>
+        </p:nvSpPr>
+        <p:spPr>
+          <a:xfrm>
+            <a:off x="9862274" y="5411297"/>
+            <a:ext cx="1128402" cy="269281"/>
+          </a:xfrm>
+          <a:prstGeom prst="rect">
+            <a:avLst/>
+          </a:prstGeom>
+          <a:solidFill>
+            <a:schemeClr val="accent6">
+              <a:lumMod val="75000"/>
+            </a:schemeClr>
+          </a:solidFill>
+        </p:spPr>
+        <p:style>
+          <a:lnRef idx="2">
+            <a:schemeClr val="accent1">
+              <a:shade val="50000"/>
+            </a:schemeClr>
+          </a:lnRef>
+          <a:fillRef idx="1">
+            <a:schemeClr val="accent1"/>
+          </a:fillRef>
+          <a:effectRef idx="0">
+            <a:schemeClr val="accent1"/>
+          </a:effectRef>
+          <a:fontRef idx="minor">
+            <a:schemeClr val="lt1"/>
+          </a:fontRef>
+        </p:style>
+        <p:txBody>
+          <a:bodyPr rtlCol="0" anchor="ctr"/>
+          <a:lstStyle/>
+          <a:p>
+            <a:pPr algn="ctr"/>
+            <a:r>
+              <a:rPr lang="en-US" sz="1400" dirty="0"/>
+              <a:t>IPv4Address</a:t>
+            </a:r>
+          </a:p>
+        </p:txBody>
+      </p:sp>
+      <p:sp>
+        <p:nvSpPr>
+          <p:cNvPr id="335" name="Rectangle 334">
+            <a:extLst>
+              <a:ext uri="{FF2B5EF4-FFF2-40B4-BE49-F238E27FC236}">
+                <a16:creationId xmlns:a16="http://schemas.microsoft.com/office/drawing/2014/main" id="{BE7881FF-F66D-A9CC-6A13-344EF13AFACE}"/>
+              </a:ext>
+            </a:extLst>
+          </p:cNvPr>
+          <p:cNvSpPr/>
+          <p:nvPr/>
+        </p:nvSpPr>
+        <p:spPr>
+          <a:xfrm>
+            <a:off x="10806199" y="6057129"/>
+            <a:ext cx="1128402" cy="269281"/>
+          </a:xfrm>
+          <a:prstGeom prst="rect">
+            <a:avLst/>
+          </a:prstGeom>
+          <a:solidFill>
+            <a:schemeClr val="accent6">
+              <a:lumMod val="75000"/>
+            </a:schemeClr>
+          </a:solidFill>
+        </p:spPr>
+        <p:style>
+          <a:lnRef idx="2">
+            <a:schemeClr val="accent1">
+              <a:shade val="50000"/>
+            </a:schemeClr>
+          </a:lnRef>
+          <a:fillRef idx="1">
+            <a:schemeClr val="accent1"/>
+          </a:fillRef>
+          <a:effectRef idx="0">
+            <a:schemeClr val="accent1"/>
+          </a:effectRef>
+          <a:fontRef idx="minor">
+            <a:schemeClr val="lt1"/>
+          </a:fontRef>
+        </p:style>
+        <p:txBody>
+          <a:bodyPr rtlCol="0" anchor="ctr"/>
+          <a:lstStyle/>
+          <a:p>
+            <a:pPr algn="ctr"/>
+            <a:r>
+              <a:rPr lang="en-US" sz="1400" dirty="0"/>
+              <a:t>IPv6Address</a:t>
+            </a:r>
+          </a:p>
+        </p:txBody>
+      </p:sp>
+      <p:cxnSp>
+        <p:nvCxnSpPr>
+          <p:cNvPr id="336" name="Straight Arrow Connector 335">
+            <a:extLst>
+              <a:ext uri="{FF2B5EF4-FFF2-40B4-BE49-F238E27FC236}">
+                <a16:creationId xmlns:a16="http://schemas.microsoft.com/office/drawing/2014/main" id="{638246A7-F45F-0102-78F3-FABF5DF65C63}"/>
+              </a:ext>
+            </a:extLst>
+          </p:cNvPr>
+          <p:cNvCxnSpPr>
+            <a:cxnSpLocks/>
+            <a:stCxn id="334" idx="0"/>
+            <a:endCxn id="332" idx="2"/>
+          </p:cNvCxnSpPr>
+          <p:nvPr/>
+        </p:nvCxnSpPr>
+        <p:spPr>
+          <a:xfrm flipV="1">
+            <a:off x="10426475" y="4911753"/>
+            <a:ext cx="454394" cy="499544"/>
+          </a:xfrm>
+          <a:prstGeom prst="straightConnector1">
+            <a:avLst/>
+          </a:prstGeom>
+          <a:ln w="44450" cap="flat">
+            <a:solidFill>
+              <a:schemeClr val="tx1"/>
+            </a:solidFill>
+            <a:miter lim="800000"/>
+            <a:headEnd w="lg" len="med"/>
+            <a:tailEnd type="triangle"/>
+          </a:ln>
+        </p:spPr>
+        <p:style>
+          <a:lnRef idx="3">
+            <a:schemeClr val="accent1"/>
+          </a:lnRef>
+          <a:fillRef idx="0">
+            <a:schemeClr val="accent1"/>
+          </a:fillRef>
+          <a:effectRef idx="2">
+            <a:schemeClr val="accent1"/>
+          </a:effectRef>
+          <a:fontRef idx="minor">
+            <a:schemeClr val="tx1"/>
+          </a:fontRef>
+        </p:style>
+      </p:cxnSp>
+      <p:cxnSp>
+        <p:nvCxnSpPr>
+          <p:cNvPr id="341" name="Straight Arrow Connector 340">
+            <a:extLst>
+              <a:ext uri="{FF2B5EF4-FFF2-40B4-BE49-F238E27FC236}">
+                <a16:creationId xmlns:a16="http://schemas.microsoft.com/office/drawing/2014/main" id="{02B68E5B-EB6F-FEBE-DFA5-4E9923479AB6}"/>
+              </a:ext>
+            </a:extLst>
+          </p:cNvPr>
+          <p:cNvCxnSpPr>
+            <a:cxnSpLocks/>
+            <a:stCxn id="335" idx="0"/>
+            <a:endCxn id="332" idx="2"/>
+          </p:cNvCxnSpPr>
+          <p:nvPr/>
+        </p:nvCxnSpPr>
+        <p:spPr>
+          <a:xfrm flipH="1" flipV="1">
+            <a:off x="10880869" y="4911753"/>
+            <a:ext cx="489531" cy="1145376"/>
+          </a:xfrm>
+          <a:prstGeom prst="straightConnector1">
+            <a:avLst/>
+          </a:prstGeom>
+          <a:ln w="44450" cap="flat">
+            <a:solidFill>
+              <a:schemeClr val="tx1"/>
+            </a:solidFill>
+            <a:miter lim="800000"/>
+            <a:headEnd w="lg" len="med"/>
+            <a:tailEnd type="triangle"/>
+          </a:ln>
+        </p:spPr>
+        <p:style>
+          <a:lnRef idx="3">
+            <a:schemeClr val="accent1"/>
+          </a:lnRef>
+          <a:fillRef idx="0">
+            <a:schemeClr val="accent1"/>
+          </a:fillRef>
+          <a:effectRef idx="2">
+            <a:schemeClr val="accent1"/>
+          </a:effectRef>
+          <a:fontRef idx="minor">
+            <a:schemeClr val="tx1"/>
+          </a:fontRef>
+        </p:style>
+      </p:cxnSp>
+      <p:sp>
+        <p:nvSpPr>
+          <p:cNvPr id="33" name="Rectangle 32">
+            <a:extLst>
+              <a:ext uri="{FF2B5EF4-FFF2-40B4-BE49-F238E27FC236}">
+                <a16:creationId xmlns:a16="http://schemas.microsoft.com/office/drawing/2014/main" id="{6464FAE8-4AB3-5592-D97E-F72A3829021B}"/>
+              </a:ext>
+            </a:extLst>
+          </p:cNvPr>
+          <p:cNvSpPr/>
+          <p:nvPr/>
+        </p:nvSpPr>
+        <p:spPr>
+          <a:xfrm>
+            <a:off x="1868261" y="3361561"/>
+            <a:ext cx="4179992" cy="271454"/>
+          </a:xfrm>
+          <a:prstGeom prst="rect">
+            <a:avLst/>
+          </a:prstGeom>
+          <a:solidFill>
+            <a:srgbClr val="7030A0"/>
+          </a:solidFill>
+        </p:spPr>
+        <p:style>
+          <a:lnRef idx="2">
+            <a:schemeClr val="accent1">
+              <a:shade val="50000"/>
+            </a:schemeClr>
+          </a:lnRef>
+          <a:fillRef idx="1">
+            <a:schemeClr val="accent1"/>
+          </a:fillRef>
+          <a:effectRef idx="0">
+            <a:schemeClr val="accent1"/>
+          </a:effectRef>
+          <a:fontRef idx="minor">
+            <a:schemeClr val="lt1"/>
+          </a:fontRef>
+        </p:style>
+        <p:txBody>
+          <a:bodyPr rtlCol="0" anchor="ctr"/>
+          <a:lstStyle/>
+          <a:p>
+            <a:pPr algn="ctr"/>
+            <a:r>
+              <a:rPr lang="en-US" sz="1400" dirty="0" err="1"/>
+              <a:t>IPAddressCollAddrConstraint</a:t>
+            </a:r>
+            <a:r>
+              <a:rPr lang="en-US" sz="1400" dirty="0"/>
+              <a:t>[</a:t>
+            </a:r>
+            <a:r>
+              <a:rPr lang="en-US" sz="1400" dirty="0" err="1"/>
+              <a:t>IPAddressTypeConstraint</a:t>
+            </a:r>
+            <a:r>
+              <a:rPr lang="en-US" sz="1400" dirty="0"/>
+              <a:t>]</a:t>
+            </a:r>
+          </a:p>
+        </p:txBody>
+      </p:sp>
+      <p:sp>
+        <p:nvSpPr>
+          <p:cNvPr id="978" name="Rectangle 977">
+            <a:extLst>
+              <a:ext uri="{FF2B5EF4-FFF2-40B4-BE49-F238E27FC236}">
+                <a16:creationId xmlns:a16="http://schemas.microsoft.com/office/drawing/2014/main" id="{1B4163B6-CDF1-610E-BE12-833183468F51}"/>
+              </a:ext>
+            </a:extLst>
+          </p:cNvPr>
+          <p:cNvSpPr/>
+          <p:nvPr/>
+        </p:nvSpPr>
+        <p:spPr>
+          <a:xfrm>
+            <a:off x="7701925" y="693493"/>
+            <a:ext cx="1406757" cy="311454"/>
+          </a:xfrm>
+          <a:prstGeom prst="rect">
+            <a:avLst/>
+          </a:prstGeom>
+          <a:solidFill>
+            <a:srgbClr val="7030A0"/>
+          </a:solidFill>
+        </p:spPr>
+        <p:style>
+          <a:lnRef idx="2">
+            <a:schemeClr val="accent1">
+              <a:shade val="50000"/>
+            </a:schemeClr>
+          </a:lnRef>
+          <a:fillRef idx="1">
+            <a:schemeClr val="accent1"/>
+          </a:fillRef>
+          <a:effectRef idx="0">
+            <a:schemeClr val="accent1"/>
+          </a:effectRef>
+          <a:fontRef idx="minor">
+            <a:schemeClr val="lt1"/>
+          </a:fontRef>
+        </p:style>
+        <p:txBody>
+          <a:bodyPr rtlCol="0" anchor="ctr"/>
+          <a:lstStyle/>
+          <a:p>
+            <a:pPr algn="ctr"/>
+            <a:r>
+              <a:rPr lang="en-US" sz="1400" dirty="0" err="1"/>
+              <a:t>IPAddressRange</a:t>
+            </a:r>
+            <a:endParaRPr lang="en-US" sz="1400" dirty="0"/>
+          </a:p>
+        </p:txBody>
+      </p:sp>
+      <p:cxnSp>
+        <p:nvCxnSpPr>
+          <p:cNvPr id="849" name="Straight Arrow Connector 848">
+            <a:extLst>
+              <a:ext uri="{FF2B5EF4-FFF2-40B4-BE49-F238E27FC236}">
+                <a16:creationId xmlns:a16="http://schemas.microsoft.com/office/drawing/2014/main" id="{0707EF7D-BF21-CBA5-8949-252C5F99314D}"/>
+              </a:ext>
+            </a:extLst>
+          </p:cNvPr>
+          <p:cNvCxnSpPr>
+            <a:cxnSpLocks/>
+            <a:stCxn id="332" idx="0"/>
+            <a:endCxn id="99" idx="2"/>
+          </p:cNvCxnSpPr>
+          <p:nvPr/>
+        </p:nvCxnSpPr>
+        <p:spPr>
+          <a:xfrm flipV="1">
+            <a:off x="10880869" y="4256884"/>
+            <a:ext cx="1" cy="385588"/>
+          </a:xfrm>
+          <a:prstGeom prst="straightConnector1">
+            <a:avLst/>
+          </a:prstGeom>
+          <a:ln w="44450" cap="flat">
+            <a:solidFill>
+              <a:schemeClr val="tx1"/>
+            </a:solidFill>
+            <a:miter lim="800000"/>
+            <a:headEnd w="lg" len="med"/>
+            <a:tailEnd type="triangle"/>
+          </a:ln>
+        </p:spPr>
+        <p:style>
+          <a:lnRef idx="3">
+            <a:schemeClr val="accent1"/>
+          </a:lnRef>
+          <a:fillRef idx="0">
+            <a:schemeClr val="accent1"/>
+          </a:fillRef>
+          <a:effectRef idx="2">
+            <a:schemeClr val="accent1"/>
+          </a:effectRef>
+          <a:fontRef idx="minor">
+            <a:schemeClr val="tx1"/>
+          </a:fontRef>
+        </p:style>
+      </p:cxnSp>
+      <p:sp>
+        <p:nvSpPr>
+          <p:cNvPr id="998" name="Rectangle 997">
+            <a:extLst>
+              <a:ext uri="{FF2B5EF4-FFF2-40B4-BE49-F238E27FC236}">
+                <a16:creationId xmlns:a16="http://schemas.microsoft.com/office/drawing/2014/main" id="{B0C617BA-1FDE-B00E-DDD1-6CD59A243D17}"/>
+              </a:ext>
+            </a:extLst>
+          </p:cNvPr>
+          <p:cNvSpPr/>
+          <p:nvPr/>
+        </p:nvSpPr>
+        <p:spPr>
+          <a:xfrm>
+            <a:off x="6291930" y="3598666"/>
+            <a:ext cx="3306073" cy="264697"/>
+          </a:xfrm>
+          <a:prstGeom prst="rect">
+            <a:avLst/>
+          </a:prstGeom>
+          <a:solidFill>
+            <a:schemeClr val="accent6">
+              <a:lumMod val="75000"/>
+            </a:schemeClr>
+          </a:solidFill>
+        </p:spPr>
+        <p:style>
+          <a:lnRef idx="2">
+            <a:schemeClr val="accent1">
+              <a:shade val="50000"/>
+            </a:schemeClr>
+          </a:lnRef>
+          <a:fillRef idx="1">
+            <a:schemeClr val="accent1"/>
+          </a:fillRef>
+          <a:effectRef idx="0">
+            <a:schemeClr val="accent1"/>
+          </a:effectRef>
+          <a:fontRef idx="minor">
+            <a:schemeClr val="lt1"/>
+          </a:fontRef>
+        </p:style>
+        <p:txBody>
+          <a:bodyPr rtlCol="0" anchor="ctr"/>
+          <a:lstStyle/>
+          <a:p>
+            <a:pPr algn="ctr"/>
+            <a:r>
+              <a:rPr lang="en-US" sz="1400" dirty="0"/>
+              <a:t>SequentialRange[</a:t>
+            </a:r>
+            <a:r>
+              <a:rPr lang="en-US" sz="1400" dirty="0" err="1"/>
+              <a:t>IPAddressTypeConstraint</a:t>
+            </a:r>
+            <a:r>
+              <a:rPr lang="en-US" sz="1400" dirty="0"/>
+              <a:t>]</a:t>
+            </a:r>
+          </a:p>
+        </p:txBody>
+      </p:sp>
+      <p:cxnSp>
+        <p:nvCxnSpPr>
+          <p:cNvPr id="1003" name="Straight Arrow Connector 1002">
+            <a:extLst>
+              <a:ext uri="{FF2B5EF4-FFF2-40B4-BE49-F238E27FC236}">
+                <a16:creationId xmlns:a16="http://schemas.microsoft.com/office/drawing/2014/main" id="{A2459840-B3DD-F37F-E819-2232D7536709}"/>
+              </a:ext>
+            </a:extLst>
+          </p:cNvPr>
+          <p:cNvCxnSpPr>
+            <a:cxnSpLocks/>
+            <a:stCxn id="105" idx="0"/>
+            <a:endCxn id="978" idx="2"/>
+          </p:cNvCxnSpPr>
+          <p:nvPr/>
+        </p:nvCxnSpPr>
+        <p:spPr>
+          <a:xfrm flipV="1">
+            <a:off x="8401139" y="1004947"/>
+            <a:ext cx="4165" cy="820493"/>
+          </a:xfrm>
+          <a:prstGeom prst="straightConnector1">
+            <a:avLst/>
+          </a:prstGeom>
+          <a:ln w="44450" cap="flat">
+            <a:solidFill>
+              <a:schemeClr val="tx1"/>
+            </a:solidFill>
+            <a:miter lim="800000"/>
+            <a:headEnd w="lg" len="med"/>
+            <a:tailEnd type="triangle"/>
+          </a:ln>
+        </p:spPr>
+        <p:style>
+          <a:lnRef idx="3">
+            <a:schemeClr val="accent1"/>
+          </a:lnRef>
+          <a:fillRef idx="0">
+            <a:schemeClr val="accent1"/>
+          </a:fillRef>
+          <a:effectRef idx="2">
+            <a:schemeClr val="accent1"/>
+          </a:effectRef>
+          <a:fontRef idx="minor">
+            <a:schemeClr val="tx1"/>
+          </a:fontRef>
+        </p:style>
+      </p:cxnSp>
+      <p:sp>
+        <p:nvSpPr>
+          <p:cNvPr id="16" name="Rectangle 15">
+            <a:extLst>
+              <a:ext uri="{FF2B5EF4-FFF2-40B4-BE49-F238E27FC236}">
+                <a16:creationId xmlns:a16="http://schemas.microsoft.com/office/drawing/2014/main" id="{CDDD8566-26CE-81FB-BBD1-B0FE77C8933D}"/>
+              </a:ext>
+            </a:extLst>
+          </p:cNvPr>
+          <p:cNvSpPr/>
+          <p:nvPr/>
+        </p:nvSpPr>
+        <p:spPr>
+          <a:xfrm>
+            <a:off x="4238857" y="2383747"/>
+            <a:ext cx="1611995" cy="271454"/>
+          </a:xfrm>
+          <a:prstGeom prst="rect">
+            <a:avLst/>
+          </a:prstGeom>
+          <a:solidFill>
+            <a:srgbClr val="7030A0"/>
+          </a:solidFill>
+        </p:spPr>
+        <p:style>
+          <a:lnRef idx="2">
+            <a:schemeClr val="accent1">
+              <a:shade val="50000"/>
+            </a:schemeClr>
+          </a:lnRef>
+          <a:fillRef idx="1">
+            <a:schemeClr val="accent1"/>
+          </a:fillRef>
+          <a:effectRef idx="0">
+            <a:schemeClr val="accent1"/>
+          </a:effectRef>
+          <a:fontRef idx="minor">
+            <a:schemeClr val="lt1"/>
+          </a:fontRef>
+        </p:style>
+        <p:txBody>
+          <a:bodyPr rtlCol="0" anchor="ctr"/>
+          <a:lstStyle/>
+          <a:p>
+            <a:pPr algn="ctr"/>
+            <a:r>
+              <a:rPr lang="en-US" sz="1400" dirty="0" err="1"/>
+              <a:t>IPAddressCollection</a:t>
+            </a:r>
+            <a:endParaRPr lang="en-US" sz="1400" dirty="0"/>
+          </a:p>
+        </p:txBody>
+      </p:sp>
+      <p:sp>
+        <p:nvSpPr>
+          <p:cNvPr id="23" name="Rectangle 22">
+            <a:extLst>
+              <a:ext uri="{FF2B5EF4-FFF2-40B4-BE49-F238E27FC236}">
+                <a16:creationId xmlns:a16="http://schemas.microsoft.com/office/drawing/2014/main" id="{EF055638-EBE3-D070-830F-13EA0DEFBAF5}"/>
+              </a:ext>
+            </a:extLst>
+          </p:cNvPr>
+          <p:cNvSpPr/>
+          <p:nvPr/>
+        </p:nvSpPr>
+        <p:spPr>
+          <a:xfrm>
+            <a:off x="1899685" y="4100385"/>
+            <a:ext cx="4117144" cy="271454"/>
+          </a:xfrm>
+          <a:prstGeom prst="rect">
+            <a:avLst/>
+          </a:prstGeom>
+          <a:solidFill>
+            <a:srgbClr val="7030A0"/>
+          </a:solidFill>
+        </p:spPr>
+        <p:style>
+          <a:lnRef idx="2">
+            <a:schemeClr val="accent1">
+              <a:shade val="50000"/>
+            </a:schemeClr>
+          </a:lnRef>
+          <a:fillRef idx="1">
+            <a:schemeClr val="accent1"/>
+          </a:fillRef>
+          <a:effectRef idx="0">
+            <a:schemeClr val="accent1"/>
+          </a:effectRef>
+          <a:fontRef idx="minor">
+            <a:schemeClr val="lt1"/>
+          </a:fontRef>
+        </p:style>
+        <p:txBody>
+          <a:bodyPr rtlCol="0" anchor="ctr"/>
+          <a:lstStyle/>
+          <a:p>
+            <a:pPr algn="ctr"/>
+            <a:r>
+              <a:rPr lang="en-US" sz="1400" dirty="0" err="1"/>
+              <a:t>IPAddressCollConstraint</a:t>
+            </a:r>
+            <a:r>
+              <a:rPr lang="en-US" sz="1400" dirty="0"/>
+              <a:t>[</a:t>
+            </a:r>
+            <a:r>
+              <a:rPr lang="en-US" sz="1400" dirty="0" err="1"/>
+              <a:t>IPAddressCollAddrConstraint</a:t>
+            </a:r>
+            <a:r>
+              <a:rPr lang="en-US" sz="1400" dirty="0"/>
+              <a:t>]</a:t>
+            </a:r>
+          </a:p>
+        </p:txBody>
+      </p:sp>
+      <p:cxnSp>
+        <p:nvCxnSpPr>
+          <p:cNvPr id="24" name="Straight Arrow Connector 23">
+            <a:extLst>
+              <a:ext uri="{FF2B5EF4-FFF2-40B4-BE49-F238E27FC236}">
+                <a16:creationId xmlns:a16="http://schemas.microsoft.com/office/drawing/2014/main" id="{E1CC9112-B421-7217-740E-F2D9FA03D624}"/>
+              </a:ext>
+            </a:extLst>
+          </p:cNvPr>
+          <p:cNvCxnSpPr>
+            <a:cxnSpLocks/>
+            <a:stCxn id="23" idx="0"/>
+            <a:endCxn id="33" idx="2"/>
+          </p:cNvCxnSpPr>
+          <p:nvPr/>
+        </p:nvCxnSpPr>
+        <p:spPr>
+          <a:xfrm flipV="1">
+            <a:off x="3958257" y="3633015"/>
+            <a:ext cx="0" cy="467370"/>
+          </a:xfrm>
+          <a:prstGeom prst="straightConnector1">
+            <a:avLst/>
+          </a:prstGeom>
+          <a:ln w="44450" cap="flat">
+            <a:solidFill>
+              <a:schemeClr val="tx1"/>
+            </a:solidFill>
+            <a:miter lim="800000"/>
+            <a:headEnd w="lg" len="med"/>
+            <a:tailEnd type="triangle"/>
+          </a:ln>
+        </p:spPr>
+        <p:style>
+          <a:lnRef idx="3">
+            <a:schemeClr val="accent1"/>
+          </a:lnRef>
+          <a:fillRef idx="0">
+            <a:schemeClr val="accent1"/>
+          </a:fillRef>
+          <a:effectRef idx="2">
+            <a:schemeClr val="accent1"/>
+          </a:effectRef>
+          <a:fontRef idx="minor">
+            <a:schemeClr val="tx1"/>
+          </a:fontRef>
+        </p:style>
+      </p:cxnSp>
+      <p:cxnSp>
+        <p:nvCxnSpPr>
+          <p:cNvPr id="32" name="Straight Arrow Connector 31">
+            <a:extLst>
+              <a:ext uri="{FF2B5EF4-FFF2-40B4-BE49-F238E27FC236}">
+                <a16:creationId xmlns:a16="http://schemas.microsoft.com/office/drawing/2014/main" id="{3EE19C60-8073-E0B8-6F18-21C3EFF7DE1F}"/>
+              </a:ext>
+            </a:extLst>
+          </p:cNvPr>
+          <p:cNvCxnSpPr>
+            <a:cxnSpLocks/>
+            <a:stCxn id="33" idx="0"/>
+            <a:endCxn id="16" idx="2"/>
+          </p:cNvCxnSpPr>
+          <p:nvPr/>
+        </p:nvCxnSpPr>
+        <p:spPr>
+          <a:xfrm flipV="1">
+            <a:off x="3958257" y="2655201"/>
+            <a:ext cx="1086598" cy="706360"/>
+          </a:xfrm>
+          <a:prstGeom prst="straightConnector1">
+            <a:avLst/>
+          </a:prstGeom>
+          <a:ln w="44450" cap="flat">
+            <a:solidFill>
+              <a:schemeClr val="tx1"/>
+            </a:solidFill>
+            <a:miter lim="800000"/>
+            <a:headEnd w="lg" len="med"/>
+            <a:tailEnd type="triangle"/>
+          </a:ln>
+        </p:spPr>
+        <p:style>
+          <a:lnRef idx="3">
+            <a:schemeClr val="accent1"/>
+          </a:lnRef>
+          <a:fillRef idx="0">
+            <a:schemeClr val="accent1"/>
+          </a:fillRef>
+          <a:effectRef idx="2">
+            <a:schemeClr val="accent1"/>
+          </a:effectRef>
+          <a:fontRef idx="minor">
+            <a:schemeClr val="tx1"/>
+          </a:fontRef>
+        </p:style>
+      </p:cxnSp>
+      <p:sp>
+        <p:nvSpPr>
+          <p:cNvPr id="49" name="Rectangle 48">
+            <a:extLst>
+              <a:ext uri="{FF2B5EF4-FFF2-40B4-BE49-F238E27FC236}">
+                <a16:creationId xmlns:a16="http://schemas.microsoft.com/office/drawing/2014/main" id="{C5742EB8-7FA7-5DB6-E708-C4D146A5A3AF}"/>
+              </a:ext>
+            </a:extLst>
+          </p:cNvPr>
+          <p:cNvSpPr/>
+          <p:nvPr/>
+        </p:nvSpPr>
+        <p:spPr>
+          <a:xfrm>
+            <a:off x="1759218" y="604623"/>
+            <a:ext cx="4414739" cy="278946"/>
+          </a:xfrm>
+          <a:prstGeom prst="rect">
+            <a:avLst/>
+          </a:prstGeom>
+          <a:solidFill>
+            <a:srgbClr val="7030A0"/>
+          </a:solidFill>
+        </p:spPr>
+        <p:style>
+          <a:lnRef idx="2">
+            <a:schemeClr val="accent1">
+              <a:shade val="50000"/>
+            </a:schemeClr>
+          </a:lnRef>
+          <a:fillRef idx="1">
+            <a:schemeClr val="accent1"/>
+          </a:fillRef>
+          <a:effectRef idx="0">
+            <a:schemeClr val="accent1"/>
+          </a:effectRef>
+          <a:fontRef idx="minor">
+            <a:schemeClr val="lt1"/>
+          </a:fontRef>
+        </p:style>
+        <p:txBody>
+          <a:bodyPr rtlCol="0" anchor="ctr"/>
+          <a:lstStyle/>
+          <a:p>
+            <a:pPr algn="ctr"/>
+            <a:r>
+              <a:rPr lang="en-US" sz="1400" dirty="0" err="1"/>
+              <a:t>IPAddressAggregationConstraint</a:t>
+            </a:r>
+            <a:r>
+              <a:rPr lang="en-US" sz="1400" dirty="0"/>
+              <a:t>[</a:t>
+            </a:r>
+            <a:r>
+              <a:rPr lang="en-US" sz="1400" dirty="0" err="1"/>
+              <a:t>IPAddressTypeConstraint</a:t>
+            </a:r>
+            <a:r>
+              <a:rPr lang="en-US" sz="1400" dirty="0"/>
+              <a:t>]</a:t>
+            </a:r>
+          </a:p>
+        </p:txBody>
+      </p:sp>
+      <p:cxnSp>
+        <p:nvCxnSpPr>
+          <p:cNvPr id="52" name="Straight Arrow Connector 51">
+            <a:extLst>
+              <a:ext uri="{FF2B5EF4-FFF2-40B4-BE49-F238E27FC236}">
+                <a16:creationId xmlns:a16="http://schemas.microsoft.com/office/drawing/2014/main" id="{653903B4-F880-C486-F407-9A45FFFE16D4}"/>
+              </a:ext>
+            </a:extLst>
+          </p:cNvPr>
+          <p:cNvCxnSpPr>
+            <a:cxnSpLocks/>
+            <a:stCxn id="33" idx="0"/>
+            <a:endCxn id="49" idx="2"/>
+          </p:cNvCxnSpPr>
+          <p:nvPr/>
+        </p:nvCxnSpPr>
+        <p:spPr>
+          <a:xfrm flipV="1">
+            <a:off x="3958257" y="883569"/>
+            <a:ext cx="8331" cy="2477992"/>
+          </a:xfrm>
+          <a:prstGeom prst="straightConnector1">
+            <a:avLst/>
+          </a:prstGeom>
+          <a:ln w="44450" cap="flat">
+            <a:solidFill>
+              <a:schemeClr val="tx1"/>
+            </a:solidFill>
+            <a:miter lim="800000"/>
+            <a:headEnd w="lg" len="med"/>
+            <a:tailEnd type="triangle"/>
+          </a:ln>
+        </p:spPr>
+        <p:style>
+          <a:lnRef idx="3">
+            <a:schemeClr val="accent1"/>
+          </a:lnRef>
+          <a:fillRef idx="0">
+            <a:schemeClr val="accent1"/>
+          </a:fillRef>
+          <a:effectRef idx="2">
+            <a:schemeClr val="accent1"/>
+          </a:effectRef>
+          <a:fontRef idx="minor">
+            <a:schemeClr val="tx1"/>
+          </a:fontRef>
+        </p:style>
+      </p:cxnSp>
+      <p:cxnSp>
+        <p:nvCxnSpPr>
+          <p:cNvPr id="65" name="Straight Arrow Connector 64">
+            <a:extLst>
+              <a:ext uri="{FF2B5EF4-FFF2-40B4-BE49-F238E27FC236}">
+                <a16:creationId xmlns:a16="http://schemas.microsoft.com/office/drawing/2014/main" id="{6C82F04B-DDC4-5199-4627-79AD94873029}"/>
+              </a:ext>
+            </a:extLst>
+          </p:cNvPr>
+          <p:cNvCxnSpPr>
+            <a:cxnSpLocks/>
+            <a:stCxn id="49" idx="0"/>
+            <a:endCxn id="4" idx="1"/>
+          </p:cNvCxnSpPr>
+          <p:nvPr/>
+        </p:nvCxnSpPr>
+        <p:spPr>
+          <a:xfrm flipV="1">
+            <a:off x="3966588" y="282919"/>
+            <a:ext cx="2019293" cy="321704"/>
+          </a:xfrm>
+          <a:prstGeom prst="straightConnector1">
+            <a:avLst/>
+          </a:prstGeom>
+          <a:ln w="44450" cap="flat">
+            <a:solidFill>
+              <a:schemeClr val="tx1"/>
+            </a:solidFill>
+            <a:miter lim="800000"/>
+            <a:headEnd w="lg" len="med"/>
+            <a:tailEnd type="triangle"/>
+          </a:ln>
+        </p:spPr>
+        <p:style>
+          <a:lnRef idx="3">
+            <a:schemeClr val="accent1"/>
+          </a:lnRef>
+          <a:fillRef idx="0">
+            <a:schemeClr val="accent1"/>
+          </a:fillRef>
+          <a:effectRef idx="2">
+            <a:schemeClr val="accent1"/>
+          </a:effectRef>
+          <a:fontRef idx="minor">
+            <a:schemeClr val="tx1"/>
+          </a:fontRef>
+        </p:style>
+      </p:cxnSp>
+      <p:sp>
+        <p:nvSpPr>
+          <p:cNvPr id="89" name="Rectangle 88">
+            <a:extLst>
+              <a:ext uri="{FF2B5EF4-FFF2-40B4-BE49-F238E27FC236}">
+                <a16:creationId xmlns:a16="http://schemas.microsoft.com/office/drawing/2014/main" id="{F4252655-6294-B62F-52C2-D947C86C42C3}"/>
+              </a:ext>
+            </a:extLst>
+          </p:cNvPr>
+          <p:cNvSpPr/>
+          <p:nvPr/>
+        </p:nvSpPr>
+        <p:spPr>
+          <a:xfrm>
+            <a:off x="10233127" y="2664787"/>
+            <a:ext cx="1273453" cy="276790"/>
+          </a:xfrm>
+          <a:prstGeom prst="rect">
+            <a:avLst/>
+          </a:prstGeom>
+          <a:solidFill>
+            <a:srgbClr val="7030A0"/>
+          </a:solidFill>
+        </p:spPr>
+        <p:style>
+          <a:lnRef idx="2">
+            <a:schemeClr val="accent1">
+              <a:shade val="50000"/>
+            </a:schemeClr>
+          </a:lnRef>
+          <a:fillRef idx="1">
+            <a:schemeClr val="accent1"/>
+          </a:fillRef>
+          <a:effectRef idx="0">
+            <a:schemeClr val="accent1"/>
+          </a:effectRef>
+          <a:fontRef idx="minor">
+            <a:schemeClr val="lt1"/>
+          </a:fontRef>
+        </p:style>
+        <p:txBody>
+          <a:bodyPr rtlCol="0" anchor="ctr"/>
+          <a:lstStyle/>
+          <a:p>
+            <a:pPr algn="ctr"/>
+            <a:r>
+              <a:rPr lang="en-US" sz="1400" dirty="0" err="1"/>
+              <a:t>IPAddressType</a:t>
+            </a:r>
+            <a:endParaRPr lang="en-US" sz="1400" dirty="0"/>
+          </a:p>
+        </p:txBody>
+      </p:sp>
+      <p:cxnSp>
+        <p:nvCxnSpPr>
+          <p:cNvPr id="92" name="Straight Arrow Connector 91">
+            <a:extLst>
+              <a:ext uri="{FF2B5EF4-FFF2-40B4-BE49-F238E27FC236}">
+                <a16:creationId xmlns:a16="http://schemas.microsoft.com/office/drawing/2014/main" id="{FFF9E8D4-D7EE-24FB-841A-7676CBC15F10}"/>
+              </a:ext>
+            </a:extLst>
+          </p:cNvPr>
+          <p:cNvCxnSpPr>
+            <a:cxnSpLocks/>
+            <a:stCxn id="89" idx="0"/>
+            <a:endCxn id="978" idx="2"/>
+          </p:cNvCxnSpPr>
+          <p:nvPr/>
+        </p:nvCxnSpPr>
+        <p:spPr>
+          <a:xfrm flipH="1" flipV="1">
+            <a:off x="8405304" y="1004947"/>
+            <a:ext cx="2464550" cy="1659840"/>
+          </a:xfrm>
+          <a:prstGeom prst="straightConnector1">
+            <a:avLst/>
+          </a:prstGeom>
+          <a:ln w="44450" cap="flat">
+            <a:solidFill>
+              <a:schemeClr val="tx1"/>
+            </a:solidFill>
+            <a:miter lim="800000"/>
+            <a:headEnd w="lg" len="med"/>
+            <a:tailEnd type="triangle"/>
+          </a:ln>
+        </p:spPr>
+        <p:style>
+          <a:lnRef idx="3">
+            <a:schemeClr val="accent1"/>
+          </a:lnRef>
+          <a:fillRef idx="0">
+            <a:schemeClr val="accent1"/>
+          </a:fillRef>
+          <a:effectRef idx="2">
+            <a:schemeClr val="accent1"/>
+          </a:effectRef>
+          <a:fontRef idx="minor">
+            <a:schemeClr val="tx1"/>
+          </a:fontRef>
+        </p:style>
+      </p:cxnSp>
+      <p:sp>
+        <p:nvSpPr>
+          <p:cNvPr id="99" name="Rectangle 98">
+            <a:extLst>
+              <a:ext uri="{FF2B5EF4-FFF2-40B4-BE49-F238E27FC236}">
+                <a16:creationId xmlns:a16="http://schemas.microsoft.com/office/drawing/2014/main" id="{B07E9CEE-0B37-945B-F69C-750531AB0CD6}"/>
+              </a:ext>
+            </a:extLst>
+          </p:cNvPr>
+          <p:cNvSpPr/>
+          <p:nvPr/>
+        </p:nvSpPr>
+        <p:spPr>
+          <a:xfrm>
+            <a:off x="9827138" y="3980094"/>
+            <a:ext cx="2107463" cy="276790"/>
+          </a:xfrm>
+          <a:prstGeom prst="rect">
+            <a:avLst/>
+          </a:prstGeom>
+          <a:solidFill>
+            <a:srgbClr val="7030A0"/>
+          </a:solidFill>
+        </p:spPr>
+        <p:style>
+          <a:lnRef idx="2">
+            <a:schemeClr val="accent1">
+              <a:shade val="50000"/>
+            </a:schemeClr>
+          </a:lnRef>
+          <a:fillRef idx="1">
+            <a:schemeClr val="accent1"/>
+          </a:fillRef>
+          <a:effectRef idx="0">
+            <a:schemeClr val="accent1"/>
+          </a:effectRef>
+          <a:fontRef idx="minor">
+            <a:schemeClr val="lt1"/>
+          </a:fontRef>
+        </p:style>
+        <p:txBody>
+          <a:bodyPr rtlCol="0" anchor="ctr"/>
+          <a:lstStyle/>
+          <a:p>
+            <a:pPr algn="ctr"/>
+            <a:r>
+              <a:rPr lang="en-US" sz="1400" dirty="0" err="1"/>
+              <a:t>IPAddressTypeConstraint</a:t>
+            </a:r>
+            <a:r>
+              <a:rPr lang="en-US" sz="1400" dirty="0"/>
+              <a:t>[]</a:t>
+            </a:r>
+          </a:p>
+        </p:txBody>
+      </p:sp>
+      <p:sp>
+        <p:nvSpPr>
+          <p:cNvPr id="105" name="Rectangle 104">
+            <a:extLst>
+              <a:ext uri="{FF2B5EF4-FFF2-40B4-BE49-F238E27FC236}">
+                <a16:creationId xmlns:a16="http://schemas.microsoft.com/office/drawing/2014/main" id="{042D1DA2-651F-9DED-C29B-6FAAD8F8585A}"/>
+              </a:ext>
+            </a:extLst>
+          </p:cNvPr>
+          <p:cNvSpPr/>
+          <p:nvPr/>
+        </p:nvSpPr>
+        <p:spPr>
+          <a:xfrm>
+            <a:off x="7396912" y="1825440"/>
+            <a:ext cx="2008453" cy="276790"/>
+          </a:xfrm>
+          <a:prstGeom prst="rect">
+            <a:avLst/>
+          </a:prstGeom>
+          <a:solidFill>
+            <a:srgbClr val="7030A0"/>
+          </a:solidFill>
+        </p:spPr>
+        <p:style>
+          <a:lnRef idx="2">
+            <a:schemeClr val="accent1">
+              <a:shade val="50000"/>
+            </a:schemeClr>
+          </a:lnRef>
+          <a:fillRef idx="1">
+            <a:schemeClr val="accent1"/>
+          </a:fillRef>
+          <a:effectRef idx="0">
+            <a:schemeClr val="accent1"/>
+          </a:effectRef>
+          <a:fontRef idx="minor">
+            <a:schemeClr val="lt1"/>
+          </a:fontRef>
+        </p:style>
+        <p:txBody>
+          <a:bodyPr rtlCol="0" anchor="ctr"/>
+          <a:lstStyle/>
+          <a:p>
+            <a:pPr algn="ctr"/>
+            <a:r>
+              <a:rPr lang="en-US" sz="1400" dirty="0" err="1"/>
+              <a:t>IPAddressSeqRangeType</a:t>
+            </a:r>
+            <a:endParaRPr lang="en-US" sz="1400" dirty="0"/>
+          </a:p>
+        </p:txBody>
+      </p:sp>
+      <p:cxnSp>
+        <p:nvCxnSpPr>
+          <p:cNvPr id="984" name="Straight Arrow Connector 983">
+            <a:extLst>
+              <a:ext uri="{FF2B5EF4-FFF2-40B4-BE49-F238E27FC236}">
+                <a16:creationId xmlns:a16="http://schemas.microsoft.com/office/drawing/2014/main" id="{7A47940F-A06E-22BF-FEE7-C563F47365C6}"/>
+              </a:ext>
+            </a:extLst>
+          </p:cNvPr>
+          <p:cNvCxnSpPr>
+            <a:cxnSpLocks/>
+            <a:stCxn id="99" idx="0"/>
+            <a:endCxn id="89" idx="2"/>
+          </p:cNvCxnSpPr>
+          <p:nvPr/>
+        </p:nvCxnSpPr>
+        <p:spPr>
+          <a:xfrm flipH="1" flipV="1">
+            <a:off x="10869854" y="2941577"/>
+            <a:ext cx="11016" cy="1038517"/>
+          </a:xfrm>
+          <a:prstGeom prst="straightConnector1">
+            <a:avLst/>
+          </a:prstGeom>
+          <a:ln w="44450" cap="flat">
+            <a:solidFill>
+              <a:schemeClr val="tx1"/>
+            </a:solidFill>
+            <a:miter lim="800000"/>
+            <a:headEnd w="lg" len="med"/>
+            <a:tailEnd type="triangle"/>
+          </a:ln>
+        </p:spPr>
+        <p:style>
+          <a:lnRef idx="3">
+            <a:schemeClr val="accent1"/>
+          </a:lnRef>
+          <a:fillRef idx="0">
+            <a:schemeClr val="accent1"/>
+          </a:fillRef>
+          <a:effectRef idx="2">
+            <a:schemeClr val="accent1"/>
+          </a:effectRef>
+          <a:fontRef idx="minor">
+            <a:schemeClr val="tx1"/>
+          </a:fontRef>
+        </p:style>
+      </p:cxnSp>
+      <p:cxnSp>
+        <p:nvCxnSpPr>
+          <p:cNvPr id="987" name="Straight Arrow Connector 986">
+            <a:extLst>
+              <a:ext uri="{FF2B5EF4-FFF2-40B4-BE49-F238E27FC236}">
+                <a16:creationId xmlns:a16="http://schemas.microsoft.com/office/drawing/2014/main" id="{0CDD9FD8-DACF-30BA-D3F0-C677456C2EC6}"/>
+              </a:ext>
+            </a:extLst>
+          </p:cNvPr>
+          <p:cNvCxnSpPr>
+            <a:cxnSpLocks/>
+            <a:stCxn id="978" idx="0"/>
+            <a:endCxn id="4" idx="3"/>
+          </p:cNvCxnSpPr>
+          <p:nvPr/>
+        </p:nvCxnSpPr>
+        <p:spPr>
+          <a:xfrm flipH="1" flipV="1">
+            <a:off x="7805973" y="282919"/>
+            <a:ext cx="599331" cy="410574"/>
+          </a:xfrm>
+          <a:prstGeom prst="straightConnector1">
+            <a:avLst/>
+          </a:prstGeom>
+          <a:ln w="44450" cap="flat">
+            <a:solidFill>
+              <a:schemeClr val="tx1"/>
+            </a:solidFill>
+            <a:miter lim="800000"/>
+            <a:headEnd w="lg" len="med"/>
+            <a:tailEnd type="triangle"/>
+          </a:ln>
+        </p:spPr>
+        <p:style>
+          <a:lnRef idx="3">
+            <a:schemeClr val="accent1"/>
+          </a:lnRef>
+          <a:fillRef idx="0">
+            <a:schemeClr val="accent1"/>
+          </a:fillRef>
+          <a:effectRef idx="2">
+            <a:schemeClr val="accent1"/>
+          </a:effectRef>
+          <a:fontRef idx="minor">
+            <a:schemeClr val="tx1"/>
+          </a:fontRef>
+        </p:style>
+      </p:cxnSp>
+      <p:cxnSp>
+        <p:nvCxnSpPr>
+          <p:cNvPr id="133" name="Straight Arrow Connector 132">
+            <a:extLst>
+              <a:ext uri="{FF2B5EF4-FFF2-40B4-BE49-F238E27FC236}">
+                <a16:creationId xmlns:a16="http://schemas.microsoft.com/office/drawing/2014/main" id="{50261668-1F82-1051-37EF-81B44658EACF}"/>
+              </a:ext>
+            </a:extLst>
+          </p:cNvPr>
+          <p:cNvCxnSpPr>
+            <a:cxnSpLocks/>
+            <a:stCxn id="998" idx="0"/>
+            <a:endCxn id="105" idx="2"/>
+          </p:cNvCxnSpPr>
+          <p:nvPr/>
+        </p:nvCxnSpPr>
+        <p:spPr>
+          <a:xfrm flipV="1">
+            <a:off x="7944967" y="2102230"/>
+            <a:ext cx="456172" cy="1496436"/>
+          </a:xfrm>
+          <a:prstGeom prst="straightConnector1">
+            <a:avLst/>
+          </a:prstGeom>
+          <a:ln w="44450" cap="flat">
+            <a:solidFill>
+              <a:schemeClr val="tx1"/>
+            </a:solidFill>
+            <a:miter lim="800000"/>
+            <a:headEnd w="lg" len="med"/>
+            <a:tailEnd type="triangle"/>
+          </a:ln>
+        </p:spPr>
+        <p:style>
+          <a:lnRef idx="3">
+            <a:schemeClr val="accent1"/>
+          </a:lnRef>
+          <a:fillRef idx="0">
+            <a:schemeClr val="accent1"/>
+          </a:fillRef>
+          <a:effectRef idx="2">
+            <a:schemeClr val="accent1"/>
+          </a:effectRef>
+          <a:fontRef idx="minor">
+            <a:schemeClr val="tx1"/>
+          </a:fontRef>
+        </p:style>
+      </p:cxnSp>
+      <p:cxnSp>
+        <p:nvCxnSpPr>
+          <p:cNvPr id="165" name="Straight Arrow Connector 164">
+            <a:extLst>
+              <a:ext uri="{FF2B5EF4-FFF2-40B4-BE49-F238E27FC236}">
+                <a16:creationId xmlns:a16="http://schemas.microsoft.com/office/drawing/2014/main" id="{43BBEF9A-5847-0222-EF45-8B1898B4C3BD}"/>
+              </a:ext>
+            </a:extLst>
+          </p:cNvPr>
+          <p:cNvCxnSpPr>
+            <a:cxnSpLocks/>
+            <a:stCxn id="998" idx="0"/>
+            <a:endCxn id="49" idx="2"/>
+          </p:cNvCxnSpPr>
+          <p:nvPr/>
+        </p:nvCxnSpPr>
+        <p:spPr>
+          <a:xfrm flipH="1" flipV="1">
+            <a:off x="3966588" y="883569"/>
+            <a:ext cx="3978379" cy="2715097"/>
+          </a:xfrm>
+          <a:prstGeom prst="straightConnector1">
+            <a:avLst/>
+          </a:prstGeom>
+          <a:ln w="44450" cap="flat">
+            <a:solidFill>
+              <a:schemeClr val="tx1"/>
+            </a:solidFill>
+            <a:miter lim="800000"/>
+            <a:headEnd w="lg" len="med"/>
+            <a:tailEnd type="triangle"/>
+          </a:ln>
+        </p:spPr>
+        <p:style>
+          <a:lnRef idx="3">
+            <a:schemeClr val="accent1"/>
+          </a:lnRef>
+          <a:fillRef idx="0">
+            <a:schemeClr val="accent1"/>
+          </a:fillRef>
+          <a:effectRef idx="2">
+            <a:schemeClr val="accent1"/>
+          </a:effectRef>
+          <a:fontRef idx="minor">
+            <a:schemeClr val="tx1"/>
+          </a:fontRef>
+        </p:style>
+      </p:cxnSp>
+      <p:cxnSp>
+        <p:nvCxnSpPr>
+          <p:cNvPr id="168" name="Straight Arrow Connector 167">
+            <a:extLst>
+              <a:ext uri="{FF2B5EF4-FFF2-40B4-BE49-F238E27FC236}">
+                <a16:creationId xmlns:a16="http://schemas.microsoft.com/office/drawing/2014/main" id="{D239AC92-A24D-D05B-36E2-8059941D3205}"/>
+              </a:ext>
+            </a:extLst>
+          </p:cNvPr>
+          <p:cNvCxnSpPr>
+            <a:cxnSpLocks/>
+            <a:stCxn id="99" idx="0"/>
+            <a:endCxn id="49" idx="2"/>
+          </p:cNvCxnSpPr>
+          <p:nvPr/>
+        </p:nvCxnSpPr>
+        <p:spPr>
+          <a:xfrm flipH="1" flipV="1">
+            <a:off x="3966588" y="883569"/>
+            <a:ext cx="6914282" cy="3096525"/>
+          </a:xfrm>
+          <a:prstGeom prst="straightConnector1">
+            <a:avLst/>
+          </a:prstGeom>
+          <a:ln w="44450" cap="flat">
+            <a:solidFill>
+              <a:schemeClr val="tx1"/>
+            </a:solidFill>
+            <a:miter lim="800000"/>
+            <a:headEnd w="lg" len="med"/>
+            <a:tailEnd type="triangle"/>
+          </a:ln>
+        </p:spPr>
+        <p:style>
+          <a:lnRef idx="3">
+            <a:schemeClr val="accent1"/>
+          </a:lnRef>
+          <a:fillRef idx="0">
+            <a:schemeClr val="accent1"/>
+          </a:fillRef>
+          <a:effectRef idx="2">
+            <a:schemeClr val="accent1"/>
+          </a:effectRef>
+          <a:fontRef idx="minor">
+            <a:schemeClr val="tx1"/>
+          </a:fontRef>
+        </p:style>
+      </p:cxnSp>
+    </p:spTree>
+    <p:extLst>
+      <p:ext uri="{BB962C8B-B14F-4D97-AF65-F5344CB8AC3E}">
+        <p14:creationId xmlns:p14="http://schemas.microsoft.com/office/powerpoint/2010/main" val="450840700"/>
+      </p:ext>
+    </p:extLst>
+  </p:cSld>
+  <p:clrMapOvr>
+    <a:masterClrMapping/>
+  </p:clrMapOvr>
+</p:sld>
+</file>
+
 <file path=ppt/theme/theme1.xml><?xml version="1.0" encoding="utf-8"?>
 <a:theme xmlns:a="http://schemas.openxmlformats.org/drawingml/2006/main" name="Office Theme">
   <a:themeElements>

</xml_diff>